<commit_message>
refactor(slides): simplify copy, make slides minimalist, and eliminate 'footing' and 'tie-out' jargon
</commit_message>
<xml_diff>
--- a/presentation/X-Ray_Audit_Copilot_Demo_Slides.pptx
+++ b/presentation/X-Ray_Audit_Copilot_Demo_Slides.pptx
@@ -3145,7 +3145,7 @@
         <p:spPr>
           <a:xfrm>
             <a:off x="731520" y="411480"/>
-            <a:ext cx="10698480" cy="365760"/>
+            <a:ext cx="10698480" cy="320040"/>
           </a:xfrm>
           <a:prstGeom prst="rect">
             <a:avLst/>
@@ -3180,7 +3180,7 @@
         <p:spPr>
           <a:xfrm>
             <a:off x="731520" y="731520"/>
-            <a:ext cx="10698480" cy="548640"/>
+            <a:ext cx="10698480" cy="502920"/>
           </a:xfrm>
           <a:prstGeom prst="rect">
             <a:avLst/>
@@ -3201,7 +3201,7 @@
               </a:defRPr>
             </a:pPr>
             <a:r>
-              <a:t>The Problem: Manual 'Tick-and-Tie' in Private Capital</a:t>
+              <a:t>The Problem: Manual Reconciliation in Private Capital</a:t>
             </a:r>
           </a:p>
         </p:txBody>
@@ -3214,7 +3214,7 @@
         </p:nvSpPr>
         <p:spPr>
           <a:xfrm>
-            <a:off x="731520" y="1280160"/>
+            <a:off x="731520" y="1234440"/>
             <a:ext cx="10698480" cy="320040"/>
           </a:xfrm>
           <a:prstGeom prst="rect">
@@ -3236,7 +3236,7 @@
               </a:defRPr>
             </a:pPr>
             <a:r>
-              <a:t>100+ quarterly auditor hours lost in a dinosaur, error-prone workflow</a:t>
+              <a:t>100+ quarterly auditor hours lost cross-referencing spreadsheets against PDF statements</a:t>
             </a:r>
           </a:p>
         </p:txBody>
@@ -3249,7 +3249,7 @@
         </p:nvSpPr>
         <p:spPr>
           <a:xfrm>
-            <a:off x="731520" y="1783080"/>
+            <a:off x="731520" y="1737360"/>
             <a:ext cx="5486400" cy="1325880"/>
           </a:xfrm>
           <a:prstGeom prst="roundRect">
@@ -3294,7 +3294,7 @@
         </p:nvSpPr>
         <p:spPr>
           <a:xfrm>
-            <a:off x="960120" y="1947672"/>
+            <a:off x="960120" y="1901952"/>
             <a:ext cx="5029200" cy="1005840"/>
           </a:xfrm>
           <a:prstGeom prst="rect">
@@ -3319,7 +3319,7 @@
               </a:defRPr>
             </a:pPr>
             <a:r>
-              <a:t>BLIND CELL DEPENDENCIES</a:t>
+              <a:t>01 • NO DOCUMENT PROVENANCE</a:t>
             </a:r>
           </a:p>
           <a:p>
@@ -3331,7 +3331,7 @@
               </a:defRPr>
             </a:pPr>
             <a:r>
-              <a:t>Complex multi-tier Excel formulas (C4 + D5 = C6) have zero character-level audit trail back to source bank statements.</a:t>
+              <a:t>Formulas like C4 + D5 = C6 reference ledger cells with zero verifiable links to source bank PDFs.</a:t>
             </a:r>
           </a:p>
         </p:txBody>
@@ -3344,7 +3344,7 @@
         </p:nvSpPr>
         <p:spPr>
           <a:xfrm>
-            <a:off x="731520" y="3291839"/>
+            <a:off x="731520" y="3246120"/>
             <a:ext cx="5486400" cy="1325880"/>
           </a:xfrm>
           <a:prstGeom prst="roundRect">
@@ -3389,7 +3389,7 @@
         </p:nvSpPr>
         <p:spPr>
           <a:xfrm>
-            <a:off x="960120" y="3456432"/>
+            <a:off x="960120" y="3410712"/>
             <a:ext cx="5029200" cy="1005840"/>
           </a:xfrm>
           <a:prstGeom prst="rect">
@@ -3414,7 +3414,7 @@
               </a:defRPr>
             </a:pPr>
             <a:r>
-              <a:t>MANUAL TRANSPOSITION ERRORS</a:t>
+              <a:t>02 • HIGH-RISK MANUAL ENTRY</a:t>
             </a:r>
           </a:p>
           <a:p>
@@ -3426,7 +3426,7 @@
               </a:defRPr>
             </a:pPr>
             <a:r>
-              <a:t>Auditors manually re-type figures from 50-page PDF bank statements into spreadsheets, risking undetected variances.</a:t>
+              <a:t>Auditors manually re-type balances across multiple funds. A single typo triggers days of reconciliation delays.</a:t>
             </a:r>
           </a:p>
         </p:txBody>
@@ -3439,7 +3439,7 @@
         </p:nvSpPr>
         <p:spPr>
           <a:xfrm>
-            <a:off x="731520" y="4800600"/>
+            <a:off x="731520" y="4754879"/>
             <a:ext cx="5486400" cy="1325880"/>
           </a:xfrm>
           <a:prstGeom prst="roundRect">
@@ -3484,7 +3484,7 @@
         </p:nvSpPr>
         <p:spPr>
           <a:xfrm>
-            <a:off x="960120" y="4965192"/>
+            <a:off x="960120" y="4919471"/>
             <a:ext cx="5029200" cy="1005840"/>
           </a:xfrm>
           <a:prstGeom prst="rect">
@@ -3509,7 +3509,7 @@
               </a:defRPr>
             </a:pPr>
             <a:r>
-              <a:t>HIDDEN AUDIT EXCEPTIONS</a:t>
+              <a:t>03 • HIDDEN EXCEPTIONS</a:t>
             </a:r>
           </a:p>
           <a:p>
@@ -3521,7 +3521,7 @@
               </a:defRPr>
             </a:pPr>
             <a:r>
-              <a:t>Suspense accounts, timing reserves, and intercompany wash accounts get buried deep in ledger rows until year-end fire drills.</a:t>
+              <a:t>Unallocated deposits and timing discrepancies stay buried in ledger rows until year-end fire drills.</a:t>
             </a:r>
           </a:p>
         </p:txBody>
@@ -3534,7 +3534,7 @@
         </p:nvSpPr>
         <p:spPr>
           <a:xfrm>
-            <a:off x="6492240" y="1783080"/>
+            <a:off x="6492240" y="1737360"/>
             <a:ext cx="4937760" cy="4343400"/>
           </a:xfrm>
           <a:prstGeom prst="roundRect">
@@ -3579,8 +3579,8 @@
         </p:nvSpPr>
         <p:spPr>
           <a:xfrm>
-            <a:off x="6812280" y="2103120"/>
-            <a:ext cx="4297680" cy="3749039"/>
+            <a:off x="6812280" y="2011680"/>
+            <a:ext cx="4297680" cy="3840480"/>
           </a:xfrm>
           <a:prstGeom prst="rect">
             <a:avLst/>
@@ -3604,13 +3604,13 @@
               </a:defRPr>
             </a:pPr>
             <a:r>
-              <a:t>INDUSTRY REALITY FROM INTERVIEWS</a:t>
+              <a:t>ORIGIN: FUND MANAGER INTERVIEWS</a:t>
             </a:r>
           </a:p>
           <a:p>
             <a:pPr>
               <a:spcAft>
-                <a:spcPts val="2000"/>
+                <a:spcPts val="2400"/>
               </a:spcAft>
               <a:defRPr sz="1500" i="1">
                 <a:solidFill>
@@ -3619,7 +3619,7 @@
               </a:defRPr>
             </a:pPr>
             <a:r>
-              <a:t>“Auditors spend up to 70% of their quarterly engagement just checking whether cash numbers in Excel actually match bank statement PDFs. It is grueling, slow, and totally unautomated.”</a:t>
+              <a:t>“Auditors spend up to 70% of quarterly reporting manually matching Excel numbers against PDF bank statements. It is slow, disconnected, and error-prone.”</a:t>
             </a:r>
           </a:p>
           <a:p>
@@ -3627,34 +3627,44 @@
               <a:spcAft>
                 <a:spcPts val="600"/>
               </a:spcAft>
-              <a:defRPr sz="1100" b="1">
+              <a:defRPr sz="1200" b="1">
                 <a:solidFill>
                   <a:srgbClr val="10B981"/>
                 </a:solidFill>
               </a:defRPr>
             </a:pPr>
             <a:r>
-              <a:t>THE IMPACT:</a:t>
+              <a:t>• 70% — MANUAL TIME</a:t>
             </a:r>
           </a:p>
           <a:p>
             <a:pPr>
-              <a:defRPr sz="1200">
-                <a:solidFill>
-                  <a:srgbClr val="94A3B8"/>
+              <a:spcAft>
+                <a:spcPts val="600"/>
+              </a:spcAft>
+              <a:defRPr sz="1200" b="1">
+                <a:solidFill>
+                  <a:srgbClr val="10B981"/>
                 </a:solidFill>
               </a:defRPr>
             </a:pPr>
             <a:r>
-              <a:t>• 2-4 weeks delay on every quarterly NAV reporting</a:t>
-            </a:r>
-            <a:br/>
-            <a:r>
-              <a:t>• High fee leakage on manual accounting consultant hours</a:t>
-            </a:r>
-            <a:br/>
-            <a:r>
-              <a:t>• Severe risk of audit qualification if discrepancies slip through</a:t>
+              <a:t>• 2-4 WKS — NAV DELAY</a:t>
+            </a:r>
+          </a:p>
+          <a:p>
+            <a:pPr>
+              <a:spcAft>
+                <a:spcPts val="600"/>
+              </a:spcAft>
+              <a:defRPr sz="1200" b="1">
+                <a:solidFill>
+                  <a:srgbClr val="10B981"/>
+                </a:solidFill>
+              </a:defRPr>
+            </a:pPr>
+            <a:r>
+              <a:t>• 100% — PROOF REQUIRED</a:t>
             </a:r>
           </a:p>
         </p:txBody>
@@ -3731,7 +3741,7 @@
         <p:spPr>
           <a:xfrm>
             <a:off x="731520" y="411480"/>
-            <a:ext cx="10698480" cy="365760"/>
+            <a:ext cx="10698480" cy="320040"/>
           </a:xfrm>
           <a:prstGeom prst="rect">
             <a:avLst/>
@@ -3752,7 +3762,7 @@
               </a:defRPr>
             </a:pPr>
             <a:r>
-              <a:t>PRODUCT OVERVIEW</a:t>
+              <a:t>AUTONOMOUS LINEAGE | PRODUCT SOLUTION</a:t>
             </a:r>
           </a:p>
         </p:txBody>
@@ -3766,7 +3776,7 @@
         <p:spPr>
           <a:xfrm>
             <a:off x="731520" y="731520"/>
-            <a:ext cx="10698480" cy="548640"/>
+            <a:ext cx="10698480" cy="502920"/>
           </a:xfrm>
           <a:prstGeom prst="rect">
             <a:avLst/>
@@ -3800,7 +3810,7 @@
         </p:nvSpPr>
         <p:spPr>
           <a:xfrm>
-            <a:off x="731520" y="1280160"/>
+            <a:off x="731520" y="1234440"/>
             <a:ext cx="10698480" cy="320040"/>
           </a:xfrm>
           <a:prstGeom prst="rect">
@@ -3822,7 +3832,7 @@
               </a:defRPr>
             </a:pPr>
             <a:r>
-              <a:t>Autonomous dual-engine financial lineage &amp; character-grounded statement verification</a:t>
+              <a:t>Dual-engine financial lineage &amp; sub-millimeter character-grounded statement matching</a:t>
             </a:r>
           </a:p>
         </p:txBody>
@@ -3835,7 +3845,7 @@
         </p:nvSpPr>
         <p:spPr>
           <a:xfrm>
-            <a:off x="731520" y="1783080"/>
+            <a:off x="731520" y="1737360"/>
             <a:ext cx="5029200" cy="1325880"/>
           </a:xfrm>
           <a:prstGeom prst="roundRect">
@@ -3880,7 +3890,7 @@
         </p:nvSpPr>
         <p:spPr>
           <a:xfrm>
-            <a:off x="960120" y="1947672"/>
+            <a:off x="960120" y="1901952"/>
             <a:ext cx="4572000" cy="1005840"/>
           </a:xfrm>
           <a:prstGeom prst="rect">
@@ -3905,7 +3915,7 @@
               </a:defRPr>
             </a:pPr>
             <a:r>
-              <a:t>1. Formula AST Parser</a:t>
+              <a:t>Engine 1 • Formula Dependency Solver</a:t>
             </a:r>
           </a:p>
           <a:p>
@@ -3917,7 +3927,7 @@
               </a:defRPr>
             </a:pPr>
             <a:r>
-              <a:t>Decodes Excel formulas (C4 + D5 = C6), extracts arithmetic terms, and maps parent-child dependency trees.</a:t>
+              <a:t>Recursively traces arithmetic formulas (C4 + D5 = C6) and maps parent-child cell lineage automatically.</a:t>
             </a:r>
           </a:p>
         </p:txBody>
@@ -3930,7 +3940,7 @@
         </p:nvSpPr>
         <p:spPr>
           <a:xfrm>
-            <a:off x="731520" y="3291839"/>
+            <a:off x="731520" y="3246120"/>
             <a:ext cx="5029200" cy="1325880"/>
           </a:xfrm>
           <a:prstGeom prst="roundRect">
@@ -3975,7 +3985,7 @@
         </p:nvSpPr>
         <p:spPr>
           <a:xfrm>
-            <a:off x="960120" y="3456432"/>
+            <a:off x="960120" y="3410712"/>
             <a:ext cx="4572000" cy="1005840"/>
           </a:xfrm>
           <a:prstGeom prst="rect">
@@ -4000,7 +4010,7 @@
               </a:defRPr>
             </a:pPr>
             <a:r>
-              <a:t>2. Automated Mathematical Footing</a:t>
+              <a:t>Engine 2 • Automated Math Verification</a:t>
             </a:r>
           </a:p>
           <a:p>
@@ -4012,7 +4022,7 @@
               </a:defRPr>
             </a:pPr>
             <a:r>
-              <a:t>Instantly verifies vertical ledger sums and cross-fund aggregations with zero-tolerance math validation.</a:t>
+              <a:t>Recalculates vertical ledger sums and cross-fund balances with zero delta tolerance.</a:t>
             </a:r>
           </a:p>
         </p:txBody>
@@ -4025,7 +4035,7 @@
         </p:nvSpPr>
         <p:spPr>
           <a:xfrm>
-            <a:off x="731520" y="4800600"/>
+            <a:off x="731520" y="4754879"/>
             <a:ext cx="5029200" cy="1325880"/>
           </a:xfrm>
           <a:prstGeom prst="roundRect">
@@ -4070,7 +4080,7 @@
         </p:nvSpPr>
         <p:spPr>
           <a:xfrm>
-            <a:off x="960120" y="4965192"/>
+            <a:off x="960120" y="4919471"/>
             <a:ext cx="4572000" cy="1005840"/>
           </a:xfrm>
           <a:prstGeom prst="rect">
@@ -4095,7 +4105,7 @@
               </a:defRPr>
             </a:pPr>
             <a:r>
-              <a:t>3. Grounded PDF Tie-Out</a:t>
+              <a:t>Engine 3 • Grounded Statement Matching</a:t>
             </a:r>
           </a:p>
           <a:p>
@@ -4107,7 +4117,7 @@
               </a:defRPr>
             </a:pPr>
             <a:r>
-              <a:t>Extracts sub-millimeter bounding boxes from PDF statements for 100% verified, zero-hallucination citations.</a:t>
+              <a:t>Extracts exact bounding boxes (bbox) from PDF statements for 100% verified citations.</a:t>
             </a:r>
           </a:p>
         </p:txBody>
@@ -4128,7 +4138,7 @@
         </p:blipFill>
         <p:spPr>
           <a:xfrm>
-            <a:off x="6035040" y="1783080"/>
+            <a:off x="6035040" y="1737360"/>
             <a:ext cx="5394960" cy="3011140"/>
           </a:xfrm>
           <a:prstGeom prst="rect">
@@ -4208,7 +4218,7 @@
         <p:spPr>
           <a:xfrm>
             <a:off x="731520" y="411480"/>
-            <a:ext cx="10698480" cy="365760"/>
+            <a:ext cx="10698480" cy="320040"/>
           </a:xfrm>
           <a:prstGeom prst="rect">
             <a:avLst/>
@@ -4229,7 +4239,7 @@
               </a:defRPr>
             </a:pPr>
             <a:r>
-              <a:t>SYSTEM ARCHITECTURE</a:t>
+              <a:t>SYSTEM DESIGN | ZERO-HALLUCINATION PIPELINE</a:t>
             </a:r>
           </a:p>
         </p:txBody>
@@ -4243,7 +4253,7 @@
         <p:spPr>
           <a:xfrm>
             <a:off x="731520" y="731520"/>
-            <a:ext cx="10698480" cy="548640"/>
+            <a:ext cx="10698480" cy="502920"/>
           </a:xfrm>
           <a:prstGeom prst="rect">
             <a:avLst/>
@@ -4264,7 +4274,7 @@
               </a:defRPr>
             </a:pPr>
             <a:r>
-              <a:t>High-Level Architecture: Zero-Hallucination Pipeline</a:t>
+              <a:t>High-Level System Architecture</a:t>
             </a:r>
           </a:p>
         </p:txBody>
@@ -4277,7 +4287,7 @@
         </p:nvSpPr>
         <p:spPr>
           <a:xfrm>
-            <a:off x="731520" y="1280160"/>
+            <a:off x="731520" y="1234440"/>
             <a:ext cx="10698480" cy="320040"/>
           </a:xfrm>
           <a:prstGeom prst="rect">
@@ -4320,8 +4330,8 @@
         </p:blipFill>
         <p:spPr>
           <a:xfrm>
-            <a:off x="731520" y="1737360"/>
-            <a:ext cx="6949440" cy="3878757"/>
+            <a:off x="731520" y="1691640"/>
+            <a:ext cx="7132320" cy="3980830"/>
           </a:xfrm>
           <a:prstGeom prst="rect">
             <a:avLst/>
@@ -4336,8 +4346,8 @@
         </p:nvSpPr>
         <p:spPr>
           <a:xfrm>
-            <a:off x="7955279" y="1737360"/>
-            <a:ext cx="3474720" cy="4389120"/>
+            <a:off x="8138160" y="1691640"/>
+            <a:ext cx="3291840" cy="4434840"/>
           </a:xfrm>
           <a:prstGeom prst="roundRect">
             <a:avLst/>
@@ -4381,8 +4391,8 @@
         </p:nvSpPr>
         <p:spPr>
           <a:xfrm>
-            <a:off x="8183879" y="1920240"/>
-            <a:ext cx="3017520" cy="4023360"/>
+            <a:off x="8366760" y="1874519"/>
+            <a:ext cx="2834640" cy="4023360"/>
           </a:xfrm>
           <a:prstGeom prst="rect">
             <a:avLst/>
@@ -4397,7 +4407,7 @@
           <a:p>
             <a:pPr>
               <a:spcAft>
-                <a:spcPts val="1000"/>
+                <a:spcPts val="1200"/>
               </a:spcAft>
               <a:defRPr sz="1100" b="1">
                 <a:solidFill>
@@ -4418,7 +4428,7 @@
               </a:defRPr>
             </a:pPr>
             <a:r>
-              <a:t>• Deterministic Parsing</a:t>
+              <a:t>• Deterministic AST</a:t>
             </a:r>
           </a:p>
           <a:p>
@@ -4433,7 +4443,7 @@
               </a:defRPr>
             </a:pPr>
             <a:r>
-              <a:t>   Formulas parsed via Python AST; no LLM guessing on math.</a:t>
+              <a:t>   Formulas parsed via Python AST; zero LLM math guessing.</a:t>
             </a:r>
           </a:p>
           <a:p>
@@ -4445,7 +4455,7 @@
               </a:defRPr>
             </a:pPr>
             <a:r>
-              <a:t>• Sub-Millimeter Bounding Boxes</a:t>
+              <a:t>• Sub-Millimeter BBox</a:t>
             </a:r>
           </a:p>
           <a:p>
@@ -4460,7 +4470,7 @@
               </a:defRPr>
             </a:pPr>
             <a:r>
-              <a:t>   Direct PDF character coordinates extracted via PyMuPDF / pdfplumber.</a:t>
+              <a:t>   Direct character coordinate extraction via PyMuPDF and pdfplumber.</a:t>
             </a:r>
           </a:p>
           <a:p>
@@ -4472,7 +4482,7 @@
               </a:defRPr>
             </a:pPr>
             <a:r>
-              <a:t>• Automated Reconciliation</a:t>
+              <a:t>• Sub-50ms Engine</a:t>
             </a:r>
           </a:p>
           <a:p>
@@ -4487,7 +4497,7 @@
               </a:defRPr>
             </a:pPr>
             <a:r>
-              <a:t>   Re-computes vertical footing &amp; cross-fund tie-outs in &lt;50ms.</a:t>
+              <a:t>   Instant cross-fund balance matching &amp; delta computation.</a:t>
             </a:r>
           </a:p>
           <a:p>
@@ -4499,7 +4509,7 @@
               </a:defRPr>
             </a:pPr>
             <a:r>
-              <a:t>• Suspense Detection</a:t>
+              <a:t>• Suspense Alerting</a:t>
             </a:r>
           </a:p>
           <a:p>
@@ -4514,7 +4524,7 @@
               </a:defRPr>
             </a:pPr>
             <a:r>
-              <a:t>   Automatically flags unresolved balances (e.g. €45,200) with audit warning badges.</a:t>
+              <a:t>   Detects unallocated deposits (e.g. €45,200) with review badges.</a:t>
             </a:r>
           </a:p>
         </p:txBody>
@@ -4591,7 +4601,7 @@
         <p:spPr>
           <a:xfrm>
             <a:off x="731520" y="411480"/>
-            <a:ext cx="10698480" cy="365760"/>
+            <a:ext cx="10698480" cy="320040"/>
           </a:xfrm>
           <a:prstGeom prst="rect">
             <a:avLst/>
@@ -4612,7 +4622,7 @@
               </a:defRPr>
             </a:pPr>
             <a:r>
-              <a:t>ENGINEERING &amp; DEPLOYMENT</a:t>
+              <a:t>ENGINEERING &amp; DELIVERY | PRODUCTION READY</a:t>
             </a:r>
           </a:p>
         </p:txBody>
@@ -4626,7 +4636,7 @@
         <p:spPr>
           <a:xfrm>
             <a:off x="731520" y="731520"/>
-            <a:ext cx="10698480" cy="548640"/>
+            <a:ext cx="10698480" cy="502920"/>
           </a:xfrm>
           <a:prstGeom prst="rect">
             <a:avLst/>
@@ -4647,7 +4657,7 @@
               </a:defRPr>
             </a:pPr>
             <a:r>
-              <a:t>Technology Stack &amp; Production Engineering</a:t>
+              <a:t>Technology Stack &amp; Turnkey Delivery</a:t>
             </a:r>
           </a:p>
         </p:txBody>
@@ -4660,7 +4670,7 @@
         </p:nvSpPr>
         <p:spPr>
           <a:xfrm>
-            <a:off x="731520" y="1280160"/>
+            <a:off x="731520" y="1234440"/>
             <a:ext cx="10698480" cy="320040"/>
           </a:xfrm>
           <a:prstGeom prst="rect">
@@ -4682,7 +4692,7 @@
               </a:defRPr>
             </a:pPr>
             <a:r>
-              <a:t>Modern, decoupled, enterprise-grade architecture with single-command Docker deployment</a:t>
+              <a:t>Modern, decoupled architecture with single-command Docker deployment</a:t>
             </a:r>
           </a:p>
         </p:txBody>
@@ -4695,7 +4705,7 @@
         </p:nvSpPr>
         <p:spPr>
           <a:xfrm>
-            <a:off x="731520" y="1783080"/>
+            <a:off x="731520" y="1737360"/>
             <a:ext cx="5212080" cy="1965960"/>
           </a:xfrm>
           <a:prstGeom prst="roundRect">
@@ -4740,7 +4750,7 @@
         </p:nvSpPr>
         <p:spPr>
           <a:xfrm>
-            <a:off x="960120" y="2011680"/>
+            <a:off x="960120" y="1965960"/>
             <a:ext cx="4754880" cy="1508760"/>
           </a:xfrm>
           <a:prstGeom prst="rect">
@@ -4765,7 +4775,7 @@
               </a:defRPr>
             </a:pPr>
             <a:r>
-              <a:t>FASTAPI BACKEND</a:t>
+              <a:t>FASTAPI &amp; PYTHON 3.11</a:t>
             </a:r>
           </a:p>
           <a:p>
@@ -4780,7 +4790,7 @@
               </a:defRPr>
             </a:pPr>
             <a:r>
-              <a:t>Python 3.11 asynchronous server with Pydantic typing, sub-50ms API response times, and modular tie-out engine services.</a:t>
+              <a:t>Asynchronous REST API, typed models, formula AST dependency solver, and sub-50ms response latency.</a:t>
             </a:r>
           </a:p>
         </p:txBody>
@@ -4793,7 +4803,7 @@
         </p:nvSpPr>
         <p:spPr>
           <a:xfrm>
-            <a:off x="6217920" y="1783080"/>
+            <a:off x="6217920" y="1737360"/>
             <a:ext cx="5212080" cy="1965960"/>
           </a:xfrm>
           <a:prstGeom prst="roundRect">
@@ -4838,7 +4848,7 @@
         </p:nvSpPr>
         <p:spPr>
           <a:xfrm>
-            <a:off x="6446520" y="2011680"/>
+            <a:off x="6446520" y="1965960"/>
             <a:ext cx="4754880" cy="1508760"/>
           </a:xfrm>
           <a:prstGeom prst="rect">
@@ -4863,7 +4873,7 @@
               </a:defRPr>
             </a:pPr>
             <a:r>
-              <a:t>PDF &amp; OCR EXTRACTION</a:t>
+              <a:t>PYMUPDF &amp; PDFPLUMBER</a:t>
             </a:r>
           </a:p>
           <a:p>
@@ -4878,7 +4888,7 @@
               </a:defRPr>
             </a:pPr>
             <a:r>
-              <a:t>PyMuPDF (fitz) + pdfplumber for character-level coordinate localization, bounding box geometry, and multi-format extraction.</a:t>
+              <a:t>Sub-millimeter character coordinate extraction, bounding box geometry, and zero hallucinations.</a:t>
             </a:r>
           </a:p>
         </p:txBody>
@@ -4961,7 +4971,7 @@
               </a:defRPr>
             </a:pPr>
             <a:r>
-              <a:t>NEXT.JS 14 FRONTEND</a:t>
+              <a:t>NEXT.JS 14 &amp; FORTUNESHEET</a:t>
             </a:r>
           </a:p>
           <a:p>
@@ -4976,7 +4986,7 @@
               </a:defRPr>
             </a:pPr>
             <a:r>
-              <a:t>React 18 App Router, Tailwind CSS, FortuneSheet virtualized spreadsheet canvas, and PDF.js synchronized split-viewer.</a:t>
+              <a:t>React 18 App Router, Tailwind CSS, virtualized spreadsheet canvas, and synchronized PDF.js split-viewer.</a:t>
             </a:r>
           </a:p>
         </p:txBody>

</xml_diff>

<commit_message>
feat(slides): prominently highlight Google Gemini 2.5 Flash & Pro across presentation deck
</commit_message>
<xml_diff>
--- a/presentation/X-Ray_Audit_Copilot_Demo_Slides.pptx
+++ b/presentation/X-Ray_Audit_Copilot_Demo_Slides.pptx
@@ -3762,7 +3762,7 @@
               </a:defRPr>
             </a:pPr>
             <a:r>
-              <a:t>AUTONOMOUS LINEAGE | PRODUCT SOLUTION</a:t>
+              <a:t>GEMINI 2.5 MULTIMODAL AI | PRODUCT SOLUTION</a:t>
             </a:r>
           </a:p>
         </p:txBody>
@@ -3832,7 +3832,7 @@
               </a:defRPr>
             </a:pPr>
             <a:r>
-              <a:t>Dual-engine financial lineage &amp; sub-millimeter character-grounded statement matching</a:t>
+              <a:t>Gemini-powered financial lineage &amp; sub-millimeter character-grounded statement matching</a:t>
             </a:r>
           </a:p>
         </p:txBody>
@@ -3915,7 +3915,7 @@
               </a:defRPr>
             </a:pPr>
             <a:r>
-              <a:t>Engine 1 • Formula Dependency Solver</a:t>
+              <a:t>Engine 1 • Gemini 2.5 Multimodal Lineage</a:t>
             </a:r>
           </a:p>
           <a:p>
@@ -3927,7 +3927,7 @@
               </a:defRPr>
             </a:pPr>
             <a:r>
-              <a:t>Recursively traces arithmetic formulas (C4 + D5 = C6) and maps parent-child cell lineage automatically.</a:t>
+              <a:t>Google Gemini multimodal understanding extracts statement metadata, accounts, and verbatim citation quotes into structured JSON.</a:t>
             </a:r>
           </a:p>
         </p:txBody>
@@ -4022,7 +4022,7 @@
               </a:defRPr>
             </a:pPr>
             <a:r>
-              <a:t>Recalculates vertical ledger sums and cross-fund balances with zero delta tolerance.</a:t>
+              <a:t>Python AST engine recalculates vertical ledger sums (C4 + D5 = C6) and cross-fund balances with zero delta.</a:t>
             </a:r>
           </a:p>
         </p:txBody>
@@ -4117,7 +4117,7 @@
               </a:defRPr>
             </a:pPr>
             <a:r>
-              <a:t>Extracts exact bounding boxes (bbox) from PDF statements for 100% verified citations.</a:t>
+              <a:t>Extracts exact bounding boxes (bbox) from PDF statements for 100% verified, non-hallucinatory citations.</a:t>
             </a:r>
           </a:p>
         </p:txBody>
@@ -4428,7 +4428,7 @@
               </a:defRPr>
             </a:pPr>
             <a:r>
-              <a:t>• Deterministic AST</a:t>
+              <a:t>• Gemini 2.5 Flash &amp; Pro</a:t>
             </a:r>
           </a:p>
           <a:p>
@@ -4443,7 +4443,7 @@
               </a:defRPr>
             </a:pPr>
             <a:r>
-              <a:t>   Formulas parsed via Python AST; zero LLM math guessing.</a:t>
+              <a:t>   Flash for rapid PDF classification; Pro for multimodal financial extraction.</a:t>
             </a:r>
           </a:p>
           <a:p>
@@ -4482,7 +4482,7 @@
               </a:defRPr>
             </a:pPr>
             <a:r>
-              <a:t>• Sub-50ms Engine</a:t>
+              <a:t>• Deterministic AST Math</a:t>
             </a:r>
           </a:p>
           <a:p>
@@ -4497,7 +4497,7 @@
               </a:defRPr>
             </a:pPr>
             <a:r>
-              <a:t>   Instant cross-fund balance matching &amp; delta computation.</a:t>
+              <a:t>   Python AST formula evaluation; zero LLM math guessing or hallucination.</a:t>
             </a:r>
           </a:p>
           <a:p>
@@ -4775,7 +4775,7 @@
               </a:defRPr>
             </a:pPr>
             <a:r>
-              <a:t>FASTAPI &amp; PYTHON 3.11</a:t>
+              <a:t>GOOGLE GEMINI 2.5 (FLASH &amp; PRO)</a:t>
             </a:r>
           </a:p>
           <a:p>
@@ -4790,7 +4790,7 @@
               </a:defRPr>
             </a:pPr>
             <a:r>
-              <a:t>Asynchronous REST API, typed models, formula AST dependency solver, and sub-50ms response latency.</a:t>
+              <a:t>Official google-genai SDK. Flash for fast PDF classification; Pro for structured financial entity &amp; quote extraction.</a:t>
             </a:r>
           </a:p>
         </p:txBody>
@@ -4873,7 +4873,7 @@
               </a:defRPr>
             </a:pPr>
             <a:r>
-              <a:t>PYMUPDF &amp; PDFPLUMBER</a:t>
+              <a:t>FASTAPI &amp; PYTHON 3.11</a:t>
             </a:r>
           </a:p>
           <a:p>
@@ -4888,7 +4888,7 @@
               </a:defRPr>
             </a:pPr>
             <a:r>
-              <a:t>Sub-millimeter character coordinate extraction, bounding box geometry, and zero hallucinations.</a:t>
+              <a:t>Asynchronous REST API, formula AST dependency solver, PyMuPDF coordinate geometry, sub-50ms latency.</a:t>
             </a:r>
           </a:p>
         </p:txBody>
@@ -5084,7 +5084,7 @@
               </a:defRPr>
             </a:pPr>
             <a:r>
-              <a:t>Single-command containerization (./run_docker.sh) running frontend, backend, and healthchecks for instant judge evaluation.</a:t>
+              <a:t>Single-command containerization (./run_docker.sh) running full stack with optional GEMINI_API_KEY or offline heuristic fallback.</a:t>
             </a:r>
           </a:p>
         </p:txBody>

</xml_diff>

<commit_message>
refactor(slides): remove mock screenshot on Slide 2, replacing with balanced 3-column engine cards
</commit_message>
<xml_diff>
--- a/presentation/X-Ray_Audit_Copilot_Demo_Slides.pptx
+++ b/presentation/X-Ray_Audit_Copilot_Demo_Slides.pptx
@@ -3845,8 +3845,8 @@
         </p:nvSpPr>
         <p:spPr>
           <a:xfrm>
-            <a:off x="731520" y="1737360"/>
-            <a:ext cx="5029200" cy="1325880"/>
+            <a:off x="731520" y="1828800"/>
+            <a:ext cx="3383280" cy="4297680"/>
           </a:xfrm>
           <a:prstGeom prst="roundRect">
             <a:avLst/>
@@ -3890,8 +3890,8 @@
         </p:nvSpPr>
         <p:spPr>
           <a:xfrm>
-            <a:off x="960120" y="1901952"/>
-            <a:ext cx="4572000" cy="1005840"/>
+            <a:off x="960120" y="2103120"/>
+            <a:ext cx="2926080" cy="3749039"/>
           </a:xfrm>
           <a:prstGeom prst="rect">
             <a:avLst/>
@@ -3906,9 +3906,9 @@
           <a:p>
             <a:pPr>
               <a:spcAft>
-                <a:spcPts val="400"/>
+                <a:spcPts val="1200"/>
               </a:spcAft>
-              <a:defRPr sz="1200" b="1">
+              <a:defRPr sz="1400" b="1">
                 <a:solidFill>
                   <a:srgbClr val="38BDF8"/>
                 </a:solidFill>
@@ -3920,7 +3920,10 @@
           </a:p>
           <a:p>
             <a:pPr>
-              <a:defRPr sz="1100">
+              <a:spcAft>
+                <a:spcPts val="1400"/>
+              </a:spcAft>
+              <a:defRPr sz="1200">
                 <a:solidFill>
                   <a:srgbClr val="94A3B8"/>
                 </a:solidFill>
@@ -3940,8 +3943,8 @@
         </p:nvSpPr>
         <p:spPr>
           <a:xfrm>
-            <a:off x="731520" y="3246120"/>
-            <a:ext cx="5029200" cy="1325880"/>
+            <a:off x="4389120" y="1828800"/>
+            <a:ext cx="3383280" cy="4297680"/>
           </a:xfrm>
           <a:prstGeom prst="roundRect">
             <a:avLst/>
@@ -3985,8 +3988,8 @@
         </p:nvSpPr>
         <p:spPr>
           <a:xfrm>
-            <a:off x="960120" y="3410712"/>
-            <a:ext cx="4572000" cy="1005840"/>
+            <a:off x="4617720" y="2103120"/>
+            <a:ext cx="2926080" cy="3749039"/>
           </a:xfrm>
           <a:prstGeom prst="rect">
             <a:avLst/>
@@ -4001,9 +4004,9 @@
           <a:p>
             <a:pPr>
               <a:spcAft>
-                <a:spcPts val="400"/>
+                <a:spcPts val="1200"/>
               </a:spcAft>
-              <a:defRPr sz="1200" b="1">
+              <a:defRPr sz="1400" b="1">
                 <a:solidFill>
                   <a:srgbClr val="10B981"/>
                 </a:solidFill>
@@ -4015,7 +4018,10 @@
           </a:p>
           <a:p>
             <a:pPr>
-              <a:defRPr sz="1100">
+              <a:spcAft>
+                <a:spcPts val="1400"/>
+              </a:spcAft>
+              <a:defRPr sz="1200">
                 <a:solidFill>
                   <a:srgbClr val="94A3B8"/>
                 </a:solidFill>
@@ -4035,8 +4041,8 @@
         </p:nvSpPr>
         <p:spPr>
           <a:xfrm>
-            <a:off x="731520" y="4754879"/>
-            <a:ext cx="5029200" cy="1325880"/>
+            <a:off x="8046720" y="1828800"/>
+            <a:ext cx="3383280" cy="4297680"/>
           </a:xfrm>
           <a:prstGeom prst="roundRect">
             <a:avLst/>
@@ -4080,8 +4086,8 @@
         </p:nvSpPr>
         <p:spPr>
           <a:xfrm>
-            <a:off x="960120" y="4919471"/>
-            <a:ext cx="4572000" cy="1005840"/>
+            <a:off x="8275320" y="2103120"/>
+            <a:ext cx="2926080" cy="3749039"/>
           </a:xfrm>
           <a:prstGeom prst="rect">
             <a:avLst/>
@@ -4096,9 +4102,9 @@
           <a:p>
             <a:pPr>
               <a:spcAft>
-                <a:spcPts val="400"/>
+                <a:spcPts val="1200"/>
               </a:spcAft>
-              <a:defRPr sz="1200" b="1">
+              <a:defRPr sz="1400" b="1">
                 <a:solidFill>
                   <a:srgbClr val="F59E0B"/>
                 </a:solidFill>
@@ -4110,7 +4116,10 @@
           </a:p>
           <a:p>
             <a:pPr>
-              <a:defRPr sz="1100">
+              <a:spcAft>
+                <a:spcPts val="1400"/>
+              </a:spcAft>
+              <a:defRPr sz="1200">
                 <a:solidFill>
                   <a:srgbClr val="94A3B8"/>
                 </a:solidFill>
@@ -4122,30 +4131,6 @@
           </a:p>
         </p:txBody>
       </p:sp>
-      <p:pic>
-        <p:nvPicPr>
-          <p:cNvPr id="12" name="Picture 11" descr="concept.jpg"/>
-          <p:cNvPicPr>
-            <a:picLocks noChangeAspect="1"/>
-          </p:cNvPicPr>
-          <p:nvPr/>
-        </p:nvPicPr>
-        <p:blipFill>
-          <a:blip r:embed="rId2"/>
-          <a:stretch>
-            <a:fillRect/>
-          </a:stretch>
-        </p:blipFill>
-        <p:spPr>
-          <a:xfrm>
-            <a:off x="6035040" y="1737360"/>
-            <a:ext cx="5394960" cy="3011140"/>
-          </a:xfrm>
-          <a:prstGeom prst="rect">
-            <a:avLst/>
-          </a:prstGeom>
-        </p:spPr>
-      </p:pic>
     </p:spTree>
   </p:cSld>
   <p:clrMapOvr>

</xml_diff>

<commit_message>
docs(presentation): make slide content concise, punchy, and minimal
</commit_message>
<xml_diff>
--- a/presentation/X-Ray_Audit_Copilot_Demo_Slides.pptx
+++ b/presentation/X-Ray_Audit_Copilot_Demo_Slides.pptx
@@ -3201,7 +3201,7 @@
               </a:defRPr>
             </a:pPr>
             <a:r>
-              <a:t>The Problem: Manual Reconciliation in Private Capital</a:t>
+              <a:t>The Problem: Manual Reconciliation</a:t>
             </a:r>
           </a:p>
         </p:txBody>
@@ -3236,7 +3236,7 @@
               </a:defRPr>
             </a:pPr>
             <a:r>
-              <a:t>100+ quarterly auditor hours lost cross-referencing spreadsheets against PDF statements</a:t>
+              <a:t>100+ quarterly hours lost manually checking spreadsheets against PDFs</a:t>
             </a:r>
           </a:p>
         </p:txBody>
@@ -3310,20 +3310,23 @@
           <a:p>
             <a:pPr>
               <a:spcAft>
-                <a:spcPts val="400"/>
+                <a:spcPts val="300"/>
               </a:spcAft>
-              <a:defRPr sz="1200" b="1">
+              <a:defRPr sz="1100" b="1">
                 <a:solidFill>
                   <a:srgbClr val="F43F5E"/>
                 </a:solidFill>
               </a:defRPr>
             </a:pPr>
             <a:r>
-              <a:t>01 • NO DOCUMENT PROVENANCE</a:t>
+              <a:t>01 • NO PROVENANCE</a:t>
             </a:r>
           </a:p>
           <a:p>
             <a:pPr>
+              <a:lnSpc>
+                <a:spcPct val="115000"/>
+              </a:lnSpc>
               <a:defRPr sz="1100">
                 <a:solidFill>
                   <a:srgbClr val="94A3B8"/>
@@ -3331,7 +3334,11 @@
               </a:defRPr>
             </a:pPr>
             <a:r>
-              <a:t>Formulas like C4 + D5 = C6 reference ledger cells with zero verifiable links to source bank PDFs.</a:t>
+              <a:t>Disconnected Formulas</a:t>
+            </a:r>
+            <a:br/>
+            <a:r>
+              <a:t>Formulas like C4 + D5 = C6 have zero link to source PDFs.</a:t>
             </a:r>
           </a:p>
         </p:txBody>
@@ -3405,20 +3412,23 @@
           <a:p>
             <a:pPr>
               <a:spcAft>
-                <a:spcPts val="400"/>
+                <a:spcPts val="300"/>
               </a:spcAft>
-              <a:defRPr sz="1200" b="1">
+              <a:defRPr sz="1100" b="1">
                 <a:solidFill>
                   <a:srgbClr val="F59E0B"/>
                 </a:solidFill>
               </a:defRPr>
             </a:pPr>
             <a:r>
-              <a:t>02 • HIGH-RISK MANUAL ENTRY</a:t>
+              <a:t>02 • HIGH RISK</a:t>
             </a:r>
           </a:p>
           <a:p>
             <a:pPr>
+              <a:lnSpc>
+                <a:spcPct val="115000"/>
+              </a:lnSpc>
               <a:defRPr sz="1100">
                 <a:solidFill>
                   <a:srgbClr val="94A3B8"/>
@@ -3426,7 +3436,11 @@
               </a:defRPr>
             </a:pPr>
             <a:r>
-              <a:t>Auditors manually re-type balances across multiple funds. A single typo triggers days of reconciliation delays.</a:t>
+              <a:t>Manual Data Entry</a:t>
+            </a:r>
+            <a:br/>
+            <a:r>
+              <a:t>Re-typing balances across funds causes delays and mistakes.</a:t>
             </a:r>
           </a:p>
         </p:txBody>
@@ -3500,20 +3514,23 @@
           <a:p>
             <a:pPr>
               <a:spcAft>
-                <a:spcPts val="400"/>
+                <a:spcPts val="300"/>
               </a:spcAft>
-              <a:defRPr sz="1200" b="1">
+              <a:defRPr sz="1100" b="1">
                 <a:solidFill>
                   <a:srgbClr val="38BDF8"/>
                 </a:solidFill>
               </a:defRPr>
             </a:pPr>
             <a:r>
-              <a:t>03 • HIDDEN EXCEPTIONS</a:t>
+              <a:t>03 • HIDDEN ISSUES</a:t>
             </a:r>
           </a:p>
           <a:p>
             <a:pPr>
+              <a:lnSpc>
+                <a:spcPct val="115000"/>
+              </a:lnSpc>
               <a:defRPr sz="1100">
                 <a:solidFill>
                   <a:srgbClr val="94A3B8"/>
@@ -3521,7 +3538,11 @@
               </a:defRPr>
             </a:pPr>
             <a:r>
-              <a:t>Unallocated deposits and timing discrepancies stay buried in ledger rows until year-end fire drills.</a:t>
+              <a:t>Buried Discrepancies</a:t>
+            </a:r>
+            <a:br/>
+            <a:r>
+              <a:t>Unallocated wires stay buried until year-end audits.</a:t>
             </a:r>
           </a:p>
         </p:txBody>
@@ -3610,16 +3631,16 @@
           <a:p>
             <a:pPr>
               <a:spcAft>
-                <a:spcPts val="2400"/>
+                <a:spcPts val="2800"/>
               </a:spcAft>
-              <a:defRPr sz="1500" i="1">
+              <a:defRPr sz="1600" i="1">
                 <a:solidFill>
                   <a:srgbClr val="FFFFFF"/>
                 </a:solidFill>
               </a:defRPr>
             </a:pPr>
             <a:r>
-              <a:t>“Auditors spend up to 70% of quarterly reporting manually matching Excel numbers against PDF bank statements. It is slow, disconnected, and error-prone.”</a:t>
+              <a:t>“Auditors spend 70% of their time manually cross-checking spreadsheets against PDFs.”</a:t>
             </a:r>
           </a:p>
           <a:p>
@@ -3634,7 +3655,7 @@
               </a:defRPr>
             </a:pPr>
             <a:r>
-              <a:t>• 70% — MANUAL TIME</a:t>
+              <a:t>• 70% — MANUAL WORK</a:t>
             </a:r>
           </a:p>
           <a:p>
@@ -3649,7 +3670,7 @@
               </a:defRPr>
             </a:pPr>
             <a:r>
-              <a:t>• 2-4 WKS — NAV DELAY</a:t>
+              <a:t>• 2-4 WKS — AUDIT DELAY</a:t>
             </a:r>
           </a:p>
           <a:p>
@@ -3664,7 +3685,7 @@
               </a:defRPr>
             </a:pPr>
             <a:r>
-              <a:t>• 100% — PROOF REQUIRED</a:t>
+              <a:t>• 100% — PROOF NEEDED</a:t>
             </a:r>
           </a:p>
         </p:txBody>
@@ -3832,7 +3853,7 @@
               </a:defRPr>
             </a:pPr>
             <a:r>
-              <a:t>Gemini-powered financial lineage &amp; sub-millimeter character-grounded statement matching</a:t>
+              <a:t>Instant lineage, verified math, and click-to-source evidence</a:t>
             </a:r>
           </a:p>
         </p:txBody>
@@ -3908,14 +3929,18 @@
               <a:spcAft>
                 <a:spcPts val="1200"/>
               </a:spcAft>
-              <a:defRPr sz="1400" b="1">
+              <a:defRPr sz="1300" b="1">
                 <a:solidFill>
                   <a:srgbClr val="38BDF8"/>
                 </a:solidFill>
               </a:defRPr>
             </a:pPr>
             <a:r>
-              <a:t>Engine 1 • Gemini 2.5 Multimodal Lineage</a:t>
+              <a:t>01 • Multimodal AI</a:t>
+            </a:r>
+            <a:br/>
+            <a:r>
+              <a:t>Gemini 2.5 Extraction</a:t>
             </a:r>
           </a:p>
           <a:p>
@@ -3923,14 +3948,23 @@
               <a:spcAft>
                 <a:spcPts val="1400"/>
               </a:spcAft>
-              <a:defRPr sz="1200">
+              <a:defRPr sz="1100">
                 <a:solidFill>
                   <a:srgbClr val="94A3B8"/>
                 </a:solidFill>
               </a:defRPr>
             </a:pPr>
             <a:r>
-              <a:t>Google Gemini multimodal understanding extracts statement metadata, accounts, and verbatim citation quotes into structured JSON.</a:t>
+              <a:t>Reads statements into structured data with exact quote citations.</a:t>
+            </a:r>
+            <a:br/>
+            <a:br/>
+            <a:r>
+              <a:t>• Verbatim quote citations</a:t>
+            </a:r>
+            <a:br/>
+            <a:r>
+              <a:t>• Multi-fund classification</a:t>
             </a:r>
           </a:p>
         </p:txBody>
@@ -4006,14 +4040,18 @@
               <a:spcAft>
                 <a:spcPts val="1200"/>
               </a:spcAft>
-              <a:defRPr sz="1400" b="1">
+              <a:defRPr sz="1300" b="1">
                 <a:solidFill>
                   <a:srgbClr val="10B981"/>
                 </a:solidFill>
               </a:defRPr>
             </a:pPr>
             <a:r>
-              <a:t>Engine 2 • Automated Math Verification</a:t>
+              <a:t>02 • Math Engine</a:t>
+            </a:r>
+            <a:br/>
+            <a:r>
+              <a:t>Deterministic Verification</a:t>
             </a:r>
           </a:p>
           <a:p>
@@ -4021,14 +4059,23 @@
               <a:spcAft>
                 <a:spcPts val="1400"/>
               </a:spcAft>
-              <a:defRPr sz="1200">
+              <a:defRPr sz="1100">
                 <a:solidFill>
                   <a:srgbClr val="94A3B8"/>
                 </a:solidFill>
               </a:defRPr>
             </a:pPr>
             <a:r>
-              <a:t>Python AST engine recalculates vertical ledger sums (C4 + D5 = C6) and cross-fund balances with zero delta.</a:t>
+              <a:t>Python AST recalculates all formulas with zero hallucinations.</a:t>
+            </a:r>
+            <a:br/>
+            <a:br/>
+            <a:r>
+              <a:t>• Zero math guessing</a:t>
+            </a:r>
+            <a:br/>
+            <a:r>
+              <a:t>• Real-time reconciliation</a:t>
             </a:r>
           </a:p>
         </p:txBody>
@@ -4104,14 +4151,18 @@
               <a:spcAft>
                 <a:spcPts val="1200"/>
               </a:spcAft>
-              <a:defRPr sz="1400" b="1">
+              <a:defRPr sz="1300" b="1">
                 <a:solidFill>
                   <a:srgbClr val="F59E0B"/>
                 </a:solidFill>
               </a:defRPr>
             </a:pPr>
             <a:r>
-              <a:t>Engine 3 • Grounded Statement Matching</a:t>
+              <a:t>03 • Source Evidence</a:t>
+            </a:r>
+            <a:br/>
+            <a:r>
+              <a:t>Click-to-Source PDF BBox</a:t>
             </a:r>
           </a:p>
           <a:p>
@@ -4119,14 +4170,23 @@
               <a:spcAft>
                 <a:spcPts val="1400"/>
               </a:spcAft>
-              <a:defRPr sz="1200">
+              <a:defRPr sz="1100">
                 <a:solidFill>
                   <a:srgbClr val="94A3B8"/>
                 </a:solidFill>
               </a:defRPr>
             </a:pPr>
             <a:r>
-              <a:t>Extracts exact bounding boxes (bbox) from PDF statements for 100% verified, non-hallucinatory citations.</a:t>
+              <a:t>PyMuPDF highlights exact character coordinates on source PDFs.</a:t>
+            </a:r>
+            <a:br/>
+            <a:br/>
+            <a:r>
+              <a:t>• Sub-millimeter bounding boxes</a:t>
+            </a:r>
+            <a:br/>
+            <a:r>
+              <a:t>• Instant cell-to-PDF jump</a:t>
             </a:r>
           </a:p>
         </p:txBody>
@@ -4224,7 +4284,7 @@
               </a:defRPr>
             </a:pPr>
             <a:r>
-              <a:t>SYSTEM DESIGN | ZERO-HALLUCINATION PIPELINE</a:t>
+              <a:t>SYSTEM PIPELINE | ZERO-HALLUCINATION</a:t>
             </a:r>
           </a:p>
         </p:txBody>
@@ -4294,7 +4354,7 @@
               </a:defRPr>
             </a:pPr>
             <a:r>
-              <a:t>Deterministic 4-stage pipeline connecting multi-fund sheets to source bank statements</a:t>
+              <a:t>4-stage pipeline connecting PDF statements to verified spreadsheets</a:t>
             </a:r>
           </a:p>
         </p:txBody>
@@ -4401,7 +4461,7 @@
               </a:defRPr>
             </a:pPr>
             <a:r>
-              <a:t>CORE GUARANTEES</a:t>
+              <a:t>CORE PIPELINE</a:t>
             </a:r>
           </a:p>
           <a:p>
@@ -4428,7 +4488,7 @@
               </a:defRPr>
             </a:pPr>
             <a:r>
-              <a:t>   Flash for rapid PDF classification; Pro for multimodal financial extraction.</a:t>
+              <a:t>   Fast PDF classification &amp; deep financial extraction.</a:t>
             </a:r>
           </a:p>
           <a:p>
@@ -4440,7 +4500,7 @@
               </a:defRPr>
             </a:pPr>
             <a:r>
-              <a:t>• Sub-Millimeter BBox</a:t>
+              <a:t>• PDF Bounding Boxes</a:t>
             </a:r>
           </a:p>
           <a:p>
@@ -4455,7 +4515,7 @@
               </a:defRPr>
             </a:pPr>
             <a:r>
-              <a:t>   Direct character coordinate extraction via PyMuPDF and pdfplumber.</a:t>
+              <a:t>   Exact visual coordinates on source documents.</a:t>
             </a:r>
           </a:p>
           <a:p>
@@ -4467,7 +4527,7 @@
               </a:defRPr>
             </a:pPr>
             <a:r>
-              <a:t>• Deterministic AST Math</a:t>
+              <a:t>• Deterministic Math</a:t>
             </a:r>
           </a:p>
           <a:p>
@@ -4482,7 +4542,7 @@
               </a:defRPr>
             </a:pPr>
             <a:r>
-              <a:t>   Python AST formula evaluation; zero LLM math guessing or hallucination.</a:t>
+              <a:t>   Python AST evaluates formulas with zero error.</a:t>
             </a:r>
           </a:p>
           <a:p>
@@ -4494,7 +4554,7 @@
               </a:defRPr>
             </a:pPr>
             <a:r>
-              <a:t>• Suspense Alerting</a:t>
+              <a:t>• Exception Quarantine</a:t>
             </a:r>
           </a:p>
           <a:p>
@@ -4509,7 +4569,7 @@
               </a:defRPr>
             </a:pPr>
             <a:r>
-              <a:t>   Detects unallocated deposits (e.g. €45,200) with review badges.</a:t>
+              <a:t>   Auto-flags unallocated items for review.</a:t>
             </a:r>
           </a:p>
         </p:txBody>
@@ -4607,7 +4667,7 @@
               </a:defRPr>
             </a:pPr>
             <a:r>
-              <a:t>ENGINEERING &amp; DELIVERY | PRODUCTION READY</a:t>
+              <a:t>TECH STACK | READY TO RUN</a:t>
             </a:r>
           </a:p>
         </p:txBody>
@@ -4642,7 +4702,7 @@
               </a:defRPr>
             </a:pPr>
             <a:r>
-              <a:t>Technology Stack &amp; Turnkey Delivery</a:t>
+              <a:t>Technology &amp; Deployment</a:t>
             </a:r>
           </a:p>
         </p:txBody>
@@ -4677,7 +4737,7 @@
               </a:defRPr>
             </a:pPr>
             <a:r>
-              <a:t>Modern, decoupled architecture with single-command Docker deployment</a:t>
+              <a:t>Modern, decoupled architecture built for production</a:t>
             </a:r>
           </a:p>
         </p:txBody>
@@ -4760,7 +4820,7 @@
               </a:defRPr>
             </a:pPr>
             <a:r>
-              <a:t>GOOGLE GEMINI 2.5 (FLASH &amp; PRO)</a:t>
+              <a:t>GOOGLE GEMINI 2.5</a:t>
             </a:r>
           </a:p>
           <a:p>
@@ -4775,7 +4835,7 @@
               </a:defRPr>
             </a:pPr>
             <a:r>
-              <a:t>Official google-genai SDK. Flash for fast PDF classification; Pro for structured financial entity &amp; quote extraction.</a:t>
+              <a:t>Gemini Flash &amp; Pro for fast classification and structured extraction.</a:t>
             </a:r>
           </a:p>
         </p:txBody>
@@ -4873,7 +4933,7 @@
               </a:defRPr>
             </a:pPr>
             <a:r>
-              <a:t>Asynchronous REST API, formula AST dependency solver, PyMuPDF coordinate geometry, sub-50ms latency.</a:t>
+              <a:t>Async API and formula AST solver with sub-50ms execution.</a:t>
             </a:r>
           </a:p>
         </p:txBody>
@@ -4971,7 +5031,7 @@
               </a:defRPr>
             </a:pPr>
             <a:r>
-              <a:t>React 18 App Router, Tailwind CSS, virtualized spreadsheet canvas, and synchronized PDF.js split-viewer.</a:t>
+              <a:t>Canvas spreadsheet synced with interactive PDF.js viewer.</a:t>
             </a:r>
           </a:p>
         </p:txBody>
@@ -5054,7 +5114,7 @@
               </a:defRPr>
             </a:pPr>
             <a:r>
-              <a:t>TURNKEY DOCKER</a:t>
+              <a:t>DOCKER &amp; COMPOSE</a:t>
             </a:r>
           </a:p>
           <a:p>
@@ -5069,7 +5129,7 @@
               </a:defRPr>
             </a:pPr>
             <a:r>
-              <a:t>Single-command containerization (./run_docker.sh) running full stack with optional GEMINI_API_KEY or offline heuristic fallback.</a:t>
+              <a:t>Single-command launch via ./run_docker.sh.</a:t>
             </a:r>
           </a:p>
         </p:txBody>

</xml_diff>